<commit_message>
Delphi overview: update to Delphi 1.0.0 (dotted names, workspace-inherit/, workspaces/ clones, park:, /ws-delphi switching slide)
</commit_message>
<xml_diff>
--- a/delphi-overview/delphi-overview.pptx
+++ b/delphi-overview/delphi-overview.pptx
@@ -17,9 +17,10 @@
     <p:sldId id="265" r:id="rId11"/>
     <p:sldId id="266" r:id="rId12"/>
     <p:sldId id="267" r:id="rId13"/>
+    <p:sldId id="268" r:id="rId14"/>
   </p:sldIdLst>
   <p:notesMasterIdLst>
-    <p:notesMasterId r:id="rId14"/>
+    <p:notesMasterId r:id="rId15"/>
   </p:notesMasterIdLst>
   <p:sldSz cx="9144000" cy="5143500"/>
   <p:notesSz cx="5143500" cy="9144000"/>
@@ -601,7 +602,7 @@
           <a:p>
             <a:r>
               <a:rPr lang="en-US" dirty="0"/>
-              <a:t>To pull something new in, edit workspace.yml (the setup-workspace skill knows the format) and re-run setup.sh; the new folders appear and stay git-ignored. Because workspace.yml is shared, PR the change into ws/&lt;name&gt; so teammates get it on their next setup. A plugin set takes effect once CI regenerates settings.json on the branch. For a one-off look, add the entry, run setup, then git restore workspace.yml. The entries here are examples.</a:t>
+              <a:t>To pull something new in, edit workspace.yml (the setup-workspace skill knows the format) and re-run setup.sh; the new folders appear and stay git-ignored. A linked workspace is a full clone on its own branch, and setup runs its setup too, so its repos are there as well. Because workspace.yml is shared, PR the change into ws/&lt;name&gt; so teammates get it on their next setup. A plugin set takes effect once CI regenerates settings.json on the branch. For a one-off look, add the entry, run setup, then git restore workspace.yml. The entries here are examples.</a:t>
             </a:r>
             <a:endParaRPr lang="en-US" dirty="0"/>
           </a:p>
@@ -689,7 +690,7 @@
           <a:p>
             <a:r>
               <a:rPr lang="en-US" dirty="0"/>
-              <a:t>When you're unsure where an edit belongs, find the row. The rule underneath: change a thing where it comes from. Workspace files through ws/&lt;name&gt;, shared context and machinery through main, code through its own repo, and personal settings nowhere at all.</a:t>
+              <a:t>You don't need a clone per workspace. In Claude Code, /ws-delphi opens a pane of every workspace, grouped by project, with this clone's marked; pick one and press Switch workspace (or /ws-delphi --web for the same cards in a browser tab). It runs .delphi/switch.sh, which refuses while tracked files have changes, then the checkout hook parks this workspace's folders, its park: list included, in .delphi/parked/&lt;name&gt;/ and brings back the new one's. The new workspace's setup runs: migrations, repos, references, plugins. No restart: skills reload and the mod sends the new CLAUDE.md with your next prompt. The delphi plugin is enabled in every workspace; setup.sh installs it.</a:t>
             </a:r>
             <a:endParaRPr lang="en-US" dirty="0"/>
           </a:p>
@@ -777,7 +778,7 @@
           <a:p>
             <a:r>
               <a:rPr lang="en-US" dirty="0"/>
-              <a:t>Three commands to a ready agent. Clone the workspace branch, run setup once, and start Claude Code at the root; the workspace's skills, glossary and repos are all there. Re-run setup after changing workspace.yml, and use switch.sh to move the same clone to another workspace or to main.</a:t>
+              <a:t>When you're unsure where an edit belongs, find the row. The rule underneath: change a thing where it comes from. Workspace files through ws/&lt;name&gt;, shared context and machinery through main, code through its own repo, and personal settings nowhere at all.</a:t>
             </a:r>
             <a:endParaRPr lang="en-US" dirty="0"/>
           </a:p>
@@ -801,6 +802,94 @@
             <a:fld id="{F7021451-1387-4CA6-816F-3879F97B5CBC}" type="slidenum">
               <a:rPr lang="en-US"/>
               <a:t>12</a:t>
+            </a:fld>
+            <a:endParaRPr lang="en-US"/>
+          </a:p>
+        </p:txBody>
+      </p:sp>
+    </p:spTree>
+    <p:extLst>
+      <p:ext uri="{BB962C8B-B14F-4D97-AF65-F5344CB8AC3E}">
+        <p14:creationId xmlns:p14="http://schemas.microsoft.com/office/powerpoint/2010/main" val="1024086991"/>
+      </p:ext>
+    </p:extLst>
+  </p:cSld>
+  <p:clrMapOvr>
+    <a:masterClrMapping/>
+  </p:clrMapOvr>
+</p:notes>
+</file>
+
+<file path=ppt/notesSlides/notesSlide13.xml><?xml version="1.0" encoding="utf-8"?>
+<p:notes xmlns:a="http://schemas.openxmlformats.org/drawingml/2006/main" xmlns:r="http://schemas.openxmlformats.org/officeDocument/2006/relationships" xmlns:p="http://schemas.openxmlformats.org/presentationml/2006/main">
+  <p:cSld>
+    <p:spTree>
+      <p:nvGrpSpPr>
+        <p:cNvPr id="1" name=""/>
+        <p:cNvGrpSpPr/>
+        <p:nvPr/>
+      </p:nvGrpSpPr>
+      <p:grpSpPr>
+        <a:xfrm>
+          <a:off x="0" y="0"/>
+          <a:ext cx="0" cy="0"/>
+          <a:chOff x="0" y="0"/>
+          <a:chExt cx="0" cy="0"/>
+        </a:xfrm>
+      </p:grpSpPr>
+      <p:sp>
+        <p:nvSpPr>
+          <p:cNvPr id="2" name="Slide Image Placeholder 1"/>
+          <p:cNvSpPr>
+            <a:spLocks noGrp="1" noRot="1" noChangeAspect="1"/>
+          </p:cNvSpPr>
+          <p:nvPr>
+            <p:ph type="sldImg"/>
+          </p:nvPr>
+        </p:nvSpPr>
+        <p:spPr/>
+      </p:sp>
+      <p:sp>
+        <p:nvSpPr>
+          <p:cNvPr id="3" name="Notes Placeholder 2"/>
+          <p:cNvSpPr>
+            <a:spLocks noGrp="1"/>
+          </p:cNvSpPr>
+          <p:nvPr>
+            <p:ph type="body" idx="1"/>
+          </p:nvPr>
+        </p:nvSpPr>
+        <p:spPr/>
+        <p:txBody>
+          <a:bodyPr/>
+          <a:lstStyle/>
+          <a:p>
+            <a:r>
+              <a:rPr lang="en-US" dirty="0"/>
+              <a:t>Three commands to a ready agent. Clone the workspace branch, run setup once, and start Claude Code at the root; the workspace's skills, glossary, repos and plugins are all there. Re-run setup after changing workspace.yml or pulling, and use /ws-delphi (or switch.sh) to move the same clone to another workspace or to main.</a:t>
+            </a:r>
+            <a:endParaRPr lang="en-US" dirty="0"/>
+          </a:p>
+        </p:txBody>
+      </p:sp>
+      <p:sp>
+        <p:nvSpPr>
+          <p:cNvPr id="4" name="Slide Number Placeholder 3"/>
+          <p:cNvSpPr>
+            <a:spLocks noGrp="1"/>
+          </p:cNvSpPr>
+          <p:nvPr>
+            <p:ph type="sldNum" sz="quarter" idx="10"/>
+          </p:nvPr>
+        </p:nvSpPr>
+        <p:spPr/>
+        <p:txBody>
+          <a:bodyPr/>
+          <a:lstStyle/>
+          <a:p>
+            <a:fld id="{F7021451-1387-4CA6-816F-3879F97B5CBC}" type="slidenum">
+              <a:rPr lang="en-US"/>
+              <a:t>13</a:t>
             </a:fld>
             <a:endParaRPr lang="en-US"/>
           </a:p>
@@ -865,7 +954,7 @@
           <a:p>
             <a:r>
               <a:rPr lang="en-US" dirty="0"/>
-              <a:t>Everything is stored once, on Delphi's main branch, as a folder per workspace under software/, laid out like the org chart. For each folder, CI keeps a branch, ws/&lt;name&gt;, whose repo root is that folder, so you clone the branch and the workspace's files sit at their normal places. The workspace's name is just its folder path with workspaces/ removed.</a:t>
+              <a:t>Everything is stored once, on Delphi's main branch, as a folder per workspace under software/, laid out like the org chart. For each folder, CI keeps a branch, ws/&lt;name&gt;, whose repo root is that folder, so you clone the branch and the workspace's files sit at their normal places, with the skills it inherits from the folders above and Delphi's scripts added. The name is each folder's short name, from software/ down, then the workspace's own folder, joined by dots: s.app.argos.argos-dev.</a:t>
             </a:r>
             <a:endParaRPr lang="en-US" dirty="0"/>
           </a:p>
@@ -953,7 +1042,7 @@
           <a:p>
             <a:r>
               <a:rPr lang="en-US" dirty="0"/>
-              <a:t>workspace.yml is the heart of a workspace. Six keys. name and harness say which workspace it is and which agent it's for. The other four each pull something in: plugins are shared skills from the folders above, repos are the code you change, references-git are dependency sources the agent reads, and workspaces are other Delphi branches to read. This is argos-dev's real file, with URLs shortened.</a:t>
+              <a:t>workspace.yml is the heart of a workspace. name and harness say which workspace it is and which agent it's for. plugins are harness plugin sets, like the delphi mod. park lists extra root folders that move aside with the workspace when you switch. The last three each check something out: repos are the code you change, references-git are dependency sources the agent reads, and workspaces are other Delphi workspaces (or main) to read. This is argos-dev's real file, trimmed, with URLs shortened.</a:t>
             </a:r>
             <a:endParaRPr lang="en-US" dirty="0"/>
           </a:p>
@@ -1041,7 +1130,7 @@
           <a:p>
             <a:r>
               <a:rPr lang="en-US" dirty="0"/>
-              <a:t>Two programs read workspace.yml. CI's ci/plugins.sh reads harness and plugins and writes .claude/settings.json, so Claude Code enables the right plugins. Your own .delphi/setup.sh reads repos, references-git and workspaces and checks each out. The checkout hook, park.sh, uses name to keep each workspace's folders apart when you switch. Everything setup makes is git-ignored, so code never shows up as a workspace change.</a:t>
+              <a:t>Two programs read workspace.yml. CI's ci/plugins.sh reads harness and plugins and writes .claude/settings.json, and setup.sh installs exactly the plugins it enables. Your own .delphi/setup.sh reads repos, references-git and workspaces and checks each out; each linked workspace is a full clone on its own branch, pulled and set up on every run. The checkout hook, park.sh, uses name and park to keep each workspace's folders apart when you switch. Everything setup makes is git-ignored, so code never shows up as a workspace change.</a:t>
             </a:r>
             <a:endParaRPr lang="en-US" dirty="0"/>
           </a:p>
@@ -1129,7 +1218,7 @@
           <a:p>
             <a:r>
               <a:rPr lang="en-US" dirty="0"/>
-              <a:t>This is the map to keep in your head. Gold files are the workspace's own: they live in its folder on main and you change them with a PR into ws/&lt;name&gt;. .delphi/ and the CI workflow are Delphi's machinery, shared by every workspace and changed only on main. settings.json is generated, never hand-edited. Plugins aren't in your clone at all: Claude Code installs them from folders higher up on main. Dashed folders are made on your machine by setup.sh, and dotted ones are yours alone.</a:t>
+              <a:t>This is the map to keep in your head. Gold files are the workspace's own: they live in its folder on main and you change them with a PR into ws/&lt;name&gt;. Purple files are inherited: the skills in each workspace-inherit/ folder above, which CI writes onto the branch on every sync, plus plugin sets like the delphi mod, which setup.sh installs. Change those on main. .delphi/ and the CI workflow are Delphi's machinery, shared by every workspace and changed only on main. settings.json is generated, never hand-edited. Dashed folders are made on your machine by setup.sh, and dotted ones are yours alone.</a:t>
             </a:r>
             <a:endParaRPr lang="en-US" dirty="0"/>
           </a:p>
@@ -1217,7 +1306,7 @@
           <a:p>
             <a:r>
               <a:rPr lang="en-US" dirty="0"/>
-              <a:t>Folders above a workspace can share context in three ways, and they behave differently. defaults/ is copied once when the workspace is created, then it's the workspace's own. Plugin sets are one shared copy: CI enables each folder's default set in every workspace below it, and Claude Code keeps it current. And with main under workspaces:, a workspace can read its project folder at linked/main/ whenever it needs to.</a:t>
+              <a:t>Folders above a workspace can share context in three ways, and they behave differently. workspace-defaults/ is copied once when the workspace is created, then it's the workspace's own. workspace-inherit/ is one shared copy on main: on every sync CI writes its files onto the branch of every workspace below that folder, so a fix there reaches all of them, and a workspace that wants its own copy lists the path under opt-out:. Plugin sets are only for what files can't do, like the delphi mod. And with main under workspaces:, a workspace reads its project folder in a clone of main at workspaces/main/.</a:t>
             </a:r>
             <a:endParaRPr lang="en-US" dirty="0"/>
           </a:p>
@@ -1305,7 +1394,7 @@
           <a:p>
             <a:r>
               <a:rPr lang="en-US" dirty="0"/>
-              <a:t>A normal ticket. You clone the workspace and run setup once. /implement makes a worktree for the ticket's branch from origin/develop and works test-first; /run-local serves that worktree; /commit applies the message format; /open-pr runs the checks and opens a draft PR into Argos develop. The skills that guide every step come from the workspace, but the code goes through Argos's own PRs. worktrees/ is git-ignored, so Delphi never sees it.</a:t>
+              <a:t>A normal ticket. You clone the workspace and run setup once. /implement makes a worktree for the ticket's branch from origin/develop and works test-first; /run-local serves that worktree; /commit applies the message format; /open-pr runs the checks and opens a draft PR into Argos develop. The skills that guide every step are inherited from the argos and application-software folders on main, but the code goes through Argos's own PRs. worktrees/ is git-ignored, so Delphi never sees it.</a:t>
             </a:r>
             <a:endParaRPr lang="en-US" dirty="0"/>
           </a:p>
@@ -1393,7 +1482,7 @@
           <a:p>
             <a:r>
               <a:rPr lang="en-US" dirty="0"/>
-              <a:t>Say /implement missed a step. Park the thought with /journal, then fix the skill on a branch of ws/&lt;name&gt; and PR it into ws/&lt;name&gt;, reviewed like code. After it merges, CI proposes it to main as a PR from propose/&lt;name&gt;; check.sh runs on it. Merge that PR with a merge commit or squash, never a rebase. CI then refreshes every workspace branch, and teammates pick it up with git merge origin/ws/&lt;name&gt;.</a:t>
+              <a:t>Say /implement missed a step. Park the thought with /journal, then fix the skill on a branch of ws/&lt;name&gt; and PR it into ws/&lt;name&gt;, reviewed like code. After it merges, CI proposes it to main as a PR from propose/&lt;name&gt;, filled from the PR template and labelled by: ai; check.sh runs on it. Merge that PR with a merge commit or squash, never a rebase. CI then refreshes every workspace branch, and teammates pick it up with git merge origin/ws/&lt;name&gt;. If the fix belongs to many workspaces, make it in a workspace-inherit/ folder on main instead.</a:t>
             </a:r>
             <a:endParaRPr lang="en-US" dirty="0"/>
           </a:p>
@@ -1481,7 +1570,7 @@
           <a:p>
             <a:r>
               <a:rPr lang="en-US" dirty="0"/>
-              <a:t>Both directions are subtree merges done by ci/sync.sh on every push to main or any ws/ branch. Refresh merges main into ws/&lt;name&gt; with the folder mapped to the root; propose does the reverse into propose/&lt;name&gt; and opens the PR. Because they're merges, histories stay joined and edits on both sides meet in a normal three-way merge. Sync also puts main's .delphi/ on every branch and regenerates settings.json, undoing hand edits to either.</a:t>
+              <a:t>Both directions are subtree merges done by ci/sync.sh on every push to main or any ws/ branch. Refresh merges main into ws/&lt;name&gt; with the folder mapped to the root; propose does the reverse into propose/&lt;name&gt; and opens the PR. Because they're merges, histories stay joined and edits on both sides meet in a normal three-way merge. Sync also puts main's .delphi/ and each workspace's inherited files on its branch and regenerates settings.json, undoing hand edits to any of them.</a:t>
             </a:r>
             <a:endParaRPr lang="en-US" dirty="0"/>
           </a:p>
@@ -1856,7 +1945,7 @@
       </p:grpSpPr>
       <p:pic>
         <p:nvPicPr>
-          <p:cNvPr id="2" name="Image 0" descr="/private/tmp/claude-501/-Users-wyattbracy-Desktop-ner-app-software-Delphi/28e5bd69-bc06-4d46-875e-7c63334f5a2a/scratchpad/build/out/pptx/01.png">    </p:cNvPr>
+          <p:cNvPr id="2" name="Image 0" descr="/private/tmp/claude-501/-Users-wyattbracy-Desktop-ner-app-software-Delphi/cc53840f-41cd-43a6-b327-f332f2602565/scratchpad/build/out/pptx/01.png">    </p:cNvPr>
           <p:cNvPicPr>
             <a:picLocks noChangeAspect="1"/>
           </p:cNvPicPr>
@@ -1912,7 +2001,7 @@
       </p:grpSpPr>
       <p:pic>
         <p:nvPicPr>
-          <p:cNvPr id="2" name="Image 0" descr="/private/tmp/claude-501/-Users-wyattbracy-Desktop-ner-app-software-Delphi/28e5bd69-bc06-4d46-875e-7c63334f5a2a/scratchpad/build/out/pptx/10.png">    </p:cNvPr>
+          <p:cNvPr id="2" name="Image 0" descr="/private/tmp/claude-501/-Users-wyattbracy-Desktop-ner-app-software-Delphi/cc53840f-41cd-43a6-b327-f332f2602565/scratchpad/build/out/pptx/10.png">    </p:cNvPr>
           <p:cNvPicPr>
             <a:picLocks noChangeAspect="1"/>
           </p:cNvPicPr>
@@ -2073,7 +2162,168 @@
       </p:grpSpPr>
       <p:pic>
         <p:nvPicPr>
-          <p:cNvPr id="2" name="Image 0" descr="/private/tmp/claude-501/-Users-wyattbracy-Desktop-ner-app-software-Delphi/28e5bd69-bc06-4d46-875e-7c63334f5a2a/scratchpad/build/out/pptx/11.png">    </p:cNvPr>
+          <p:cNvPr id="2" name="Image 0" descr="/private/tmp/claude-501/-Users-wyattbracy-Desktop-ner-app-software-Delphi/cc53840f-41cd-43a6-b327-f332f2602565/scratchpad/build/out/pptx/11.png">    </p:cNvPr>
+          <p:cNvPicPr>
+            <a:picLocks noChangeAspect="1"/>
+          </p:cNvPicPr>
+          <p:nvPr/>
+        </p:nvPicPr>
+        <p:blipFill>
+          <a:blip r:embed="rId1"/>
+          <a:stretch>
+            <a:fillRect/>
+          </a:stretch>
+        </p:blipFill>
+        <p:spPr>
+          <a:xfrm>
+            <a:off x="0" y="0"/>
+            <a:ext cx="9144000" cy="5143500"/>
+          </a:xfrm>
+          <a:prstGeom prst="rect">
+            <a:avLst/>
+          </a:prstGeom>
+        </p:spPr>
+      </p:pic>
+      <p:sp>
+        <p:nvSpPr>
+          <p:cNvPr id="3" name="Shape 0"/>
+          <p:cNvSpPr/>
+          <p:nvPr/>
+        </p:nvSpPr>
+        <p:spPr>
+          <a:xfrm>
+            <a:off x="457200" y="331470"/>
+            <a:ext cx="85725" cy="85725"/>
+          </a:xfrm>
+          <a:prstGeom prst="rect">
+            <a:avLst/>
+          </a:prstGeom>
+          <a:solidFill>
+            <a:srgbClr val="B9821F"/>
+          </a:solidFill>
+          <a:ln w="12700">
+            <a:solidFill>
+              <a:srgbClr val="B9821F"/>
+            </a:solidFill>
+            <a:prstDash val="solid"/>
+          </a:ln>
+        </p:spPr>
+      </p:sp>
+      <p:sp>
+        <p:nvSpPr>
+          <p:cNvPr id="4" name="Text 1"/>
+          <p:cNvSpPr/>
+          <p:nvPr/>
+        </p:nvSpPr>
+        <p:spPr>
+          <a:xfrm>
+            <a:off x="617220" y="297180"/>
+            <a:ext cx="6400800" cy="148590"/>
+          </a:xfrm>
+          <a:prstGeom prst="rect">
+            <a:avLst/>
+          </a:prstGeom>
+          <a:noFill/>
+          <a:ln/>
+        </p:spPr>
+        <p:txBody>
+          <a:bodyPr wrap="square" lIns="0" tIns="0" rIns="0" bIns="0" rtlCol="0" anchor="ctr"/>
+          <a:lstStyle/>
+          <a:p>
+            <a:pPr indent="0" marL="0">
+              <a:buNone/>
+            </a:pPr>
+            <a:r>
+              <a:rPr lang="en-US" sz="810" b="1" spc="160" kern="0" dirty="0">
+                <a:solidFill>
+                  <a:srgbClr val="B9821F"/>
+                </a:solidFill>
+                <a:latin typeface="Helvetica Neue" pitchFamily="34" charset="0"/>
+                <a:ea typeface="Helvetica Neue" pitchFamily="34" charset="-122"/>
+                <a:cs typeface="Helvetica Neue" pitchFamily="34" charset="-120"/>
+              </a:rPr>
+              <a:t>SWITCHING</a:t>
+            </a:r>
+            <a:endParaRPr lang="en-US" sz="810" dirty="0"/>
+          </a:p>
+        </p:txBody>
+      </p:sp>
+      <p:sp>
+        <p:nvSpPr>
+          <p:cNvPr id="5" name="Text 2"/>
+          <p:cNvSpPr/>
+          <p:nvPr/>
+        </p:nvSpPr>
+        <p:spPr>
+          <a:xfrm>
+            <a:off x="457200" y="502920"/>
+            <a:ext cx="8229600" cy="365760"/>
+          </a:xfrm>
+          <a:prstGeom prst="rect">
+            <a:avLst/>
+          </a:prstGeom>
+          <a:noFill/>
+          <a:ln/>
+        </p:spPr>
+        <p:txBody>
+          <a:bodyPr wrap="square" lIns="0" tIns="0" rIns="0" bIns="0" rtlCol="0" anchor="ctr">
+            <a:normAutofit/>
+          </a:bodyPr>
+          <a:lstStyle/>
+          <a:p>
+            <a:pPr indent="0" marL="0">
+              <a:buNone/>
+            </a:pPr>
+            <a:r>
+              <a:rPr lang="en-US" sz="2250" b="1" dirty="0">
+                <a:solidFill>
+                  <a:srgbClr val="1C2230"/>
+                </a:solidFill>
+                <a:latin typeface="Georgia" pitchFamily="34" charset="0"/>
+                <a:ea typeface="Georgia" pitchFamily="34" charset="-122"/>
+                <a:cs typeface="Georgia" pitchFamily="34" charset="-120"/>
+              </a:rPr>
+              <a:t>One clone, any workspace: /ws-delphi</a:t>
+            </a:r>
+            <a:endParaRPr lang="en-US" sz="2250" dirty="0"/>
+          </a:p>
+        </p:txBody>
+      </p:sp>
+    </p:spTree>
+  </p:cSld>
+  <p:clrMapOvr>
+    <a:masterClrMapping/>
+  </p:clrMapOvr>
+</p:sld>
+</file>
+
+<file path=ppt/slides/slide12.xml><?xml version="1.0" encoding="utf-8"?>
+<p:sld xmlns:a="http://schemas.openxmlformats.org/drawingml/2006/main" xmlns:r="http://schemas.openxmlformats.org/officeDocument/2006/relationships" xmlns:p="http://schemas.openxmlformats.org/presentationml/2006/main">
+  <p:cSld name="Slide 12">
+    <p:bg>
+      <p:bgPr>
+        <a:solidFill>
+          <a:srgbClr val="F7F4EE"/>
+        </a:solidFill>
+      </p:bgPr>
+    </p:bg>
+    <p:spTree>
+      <p:nvGrpSpPr>
+        <p:cNvPr id="1" name=""/>
+        <p:cNvGrpSpPr/>
+        <p:nvPr/>
+      </p:nvGrpSpPr>
+      <p:grpSpPr>
+        <a:xfrm>
+          <a:off x="0" y="0"/>
+          <a:ext cx="0" cy="0"/>
+          <a:chOff x="0" y="0"/>
+          <a:chExt cx="0" cy="0"/>
+        </a:xfrm>
+      </p:grpSpPr>
+      <p:pic>
+        <p:nvPicPr>
+          <p:cNvPr id="2" name="Image 0" descr="/private/tmp/claude-501/-Users-wyattbracy-Desktop-ner-app-software-Delphi/cc53840f-41cd-43a6-b327-f332f2602565/scratchpad/build/out/pptx/12.png">    </p:cNvPr>
           <p:cNvPicPr>
             <a:picLocks noChangeAspect="1"/>
           </p:cNvPicPr>
@@ -2208,9 +2458,9 @@
 </p:sld>
 </file>
 
-<file path=ppt/slides/slide12.xml><?xml version="1.0" encoding="utf-8"?>
+<file path=ppt/slides/slide13.xml><?xml version="1.0" encoding="utf-8"?>
 <p:sld xmlns:a="http://schemas.openxmlformats.org/drawingml/2006/main" xmlns:r="http://schemas.openxmlformats.org/officeDocument/2006/relationships" xmlns:p="http://schemas.openxmlformats.org/presentationml/2006/main">
-  <p:cSld name="Slide 12">
+  <p:cSld name="Slide 13">
     <p:bg>
       <p:bgPr>
         <a:solidFill>
@@ -2234,7 +2484,7 @@
       </p:grpSpPr>
       <p:pic>
         <p:nvPicPr>
-          <p:cNvPr id="2" name="Image 0" descr="/private/tmp/claude-501/-Users-wyattbracy-Desktop-ner-app-software-Delphi/28e5bd69-bc06-4d46-875e-7c63334f5a2a/scratchpad/build/out/pptx/12.png">    </p:cNvPr>
+          <p:cNvPr id="2" name="Image 0" descr="/private/tmp/claude-501/-Users-wyattbracy-Desktop-ner-app-software-Delphi/cc53840f-41cd-43a6-b327-f332f2602565/scratchpad/build/out/pptx/13.png">    </p:cNvPr>
           <p:cNvPicPr>
             <a:picLocks noChangeAspect="1"/>
           </p:cNvPicPr>
@@ -2290,7 +2540,7 @@
       </p:grpSpPr>
       <p:pic>
         <p:nvPicPr>
-          <p:cNvPr id="2" name="Image 0" descr="/private/tmp/claude-501/-Users-wyattbracy-Desktop-ner-app-software-Delphi/28e5bd69-bc06-4d46-875e-7c63334f5a2a/scratchpad/build/out/pptx/02.png">    </p:cNvPr>
+          <p:cNvPr id="2" name="Image 0" descr="/private/tmp/claude-501/-Users-wyattbracy-Desktop-ner-app-software-Delphi/cc53840f-41cd-43a6-b327-f332f2602565/scratchpad/build/out/pptx/02.png">    </p:cNvPr>
           <p:cNvPicPr>
             <a:picLocks noChangeAspect="1"/>
           </p:cNvPicPr>
@@ -2451,7 +2701,7 @@
       </p:grpSpPr>
       <p:pic>
         <p:nvPicPr>
-          <p:cNvPr id="2" name="Image 0" descr="/private/tmp/claude-501/-Users-wyattbracy-Desktop-ner-app-software-Delphi/28e5bd69-bc06-4d46-875e-7c63334f5a2a/scratchpad/build/out/pptx/03.png">    </p:cNvPr>
+          <p:cNvPr id="2" name="Image 0" descr="/private/tmp/claude-501/-Users-wyattbracy-Desktop-ner-app-software-Delphi/cc53840f-41cd-43a6-b327-f332f2602565/scratchpad/build/out/pptx/03.png">    </p:cNvPr>
           <p:cNvPicPr>
             <a:picLocks noChangeAspect="1"/>
           </p:cNvPicPr>
@@ -2612,7 +2862,7 @@
       </p:grpSpPr>
       <p:pic>
         <p:nvPicPr>
-          <p:cNvPr id="2" name="Image 0" descr="/private/tmp/claude-501/-Users-wyattbracy-Desktop-ner-app-software-Delphi/28e5bd69-bc06-4d46-875e-7c63334f5a2a/scratchpad/build/out/pptx/04.png">    </p:cNvPr>
+          <p:cNvPr id="2" name="Image 0" descr="/private/tmp/claude-501/-Users-wyattbracy-Desktop-ner-app-software-Delphi/cc53840f-41cd-43a6-b327-f332f2602565/scratchpad/build/out/pptx/04.png">    </p:cNvPr>
           <p:cNvPicPr>
             <a:picLocks noChangeAspect="1"/>
           </p:cNvPicPr>
@@ -2773,7 +3023,7 @@
       </p:grpSpPr>
       <p:pic>
         <p:nvPicPr>
-          <p:cNvPr id="2" name="Image 0" descr="/private/tmp/claude-501/-Users-wyattbracy-Desktop-ner-app-software-Delphi/28e5bd69-bc06-4d46-875e-7c63334f5a2a/scratchpad/build/out/pptx/05.png">    </p:cNvPr>
+          <p:cNvPr id="2" name="Image 0" descr="/private/tmp/claude-501/-Users-wyattbracy-Desktop-ner-app-software-Delphi/cc53840f-41cd-43a6-b327-f332f2602565/scratchpad/build/out/pptx/05.png">    </p:cNvPr>
           <p:cNvPicPr>
             <a:picLocks noChangeAspect="1"/>
           </p:cNvPicPr>
@@ -2934,7 +3184,7 @@
       </p:grpSpPr>
       <p:pic>
         <p:nvPicPr>
-          <p:cNvPr id="2" name="Image 0" descr="/private/tmp/claude-501/-Users-wyattbracy-Desktop-ner-app-software-Delphi/28e5bd69-bc06-4d46-875e-7c63334f5a2a/scratchpad/build/out/pptx/06.png">    </p:cNvPr>
+          <p:cNvPr id="2" name="Image 0" descr="/private/tmp/claude-501/-Users-wyattbracy-Desktop-ner-app-software-Delphi/cc53840f-41cd-43a6-b327-f332f2602565/scratchpad/build/out/pptx/06.png">    </p:cNvPr>
           <p:cNvPicPr>
             <a:picLocks noChangeAspect="1"/>
           </p:cNvPicPr>
@@ -3095,7 +3345,7 @@
       </p:grpSpPr>
       <p:pic>
         <p:nvPicPr>
-          <p:cNvPr id="2" name="Image 0" descr="/private/tmp/claude-501/-Users-wyattbracy-Desktop-ner-app-software-Delphi/28e5bd69-bc06-4d46-875e-7c63334f5a2a/scratchpad/build/out/pptx/07.png">    </p:cNvPr>
+          <p:cNvPr id="2" name="Image 0" descr="/private/tmp/claude-501/-Users-wyattbracy-Desktop-ner-app-software-Delphi/cc53840f-41cd-43a6-b327-f332f2602565/scratchpad/build/out/pptx/07.png">    </p:cNvPr>
           <p:cNvPicPr>
             <a:picLocks noChangeAspect="1"/>
           </p:cNvPicPr>
@@ -3256,7 +3506,7 @@
       </p:grpSpPr>
       <p:pic>
         <p:nvPicPr>
-          <p:cNvPr id="2" name="Image 0" descr="/private/tmp/claude-501/-Users-wyattbracy-Desktop-ner-app-software-Delphi/28e5bd69-bc06-4d46-875e-7c63334f5a2a/scratchpad/build/out/pptx/08.png">    </p:cNvPr>
+          <p:cNvPr id="2" name="Image 0" descr="/private/tmp/claude-501/-Users-wyattbracy-Desktop-ner-app-software-Delphi/cc53840f-41cd-43a6-b327-f332f2602565/scratchpad/build/out/pptx/08.png">    </p:cNvPr>
           <p:cNvPicPr>
             <a:picLocks noChangeAspect="1"/>
           </p:cNvPicPr>
@@ -3417,7 +3667,7 @@
       </p:grpSpPr>
       <p:pic>
         <p:nvPicPr>
-          <p:cNvPr id="2" name="Image 0" descr="/private/tmp/claude-501/-Users-wyattbracy-Desktop-ner-app-software-Delphi/28e5bd69-bc06-4d46-875e-7c63334f5a2a/scratchpad/build/out/pptx/09.png">    </p:cNvPr>
+          <p:cNvPr id="2" name="Image 0" descr="/private/tmp/claude-501/-Users-wyattbracy-Desktop-ner-app-software-Delphi/cc53840f-41cd-43a6-b327-f332f2602565/scratchpad/build/out/pptx/09.png">    </p:cNvPr>
           <p:cNvPicPr>
             <a:picLocks noChangeAspect="1"/>
           </p:cNvPicPr>

</xml_diff>

<commit_message>
Delphi overview: update to Delphi 1.2.0 (repos/ plain clone, worktrees from worktrees/<repo>/.bare; open-pr screenshots)
</commit_message>
<xml_diff>
--- a/delphi-overview/delphi-overview.pptx
+++ b/delphi-overview/delphi-overview.pptx
@@ -1130,7 +1130,7 @@
           <a:p>
             <a:r>
               <a:rPr lang="en-US" dirty="0"/>
-              <a:t>Two programs read workspace.yml. CI's ci/plugins.sh reads harness and plugins and writes .claude/settings.json, and setup.sh installs exactly the plugins it enables. Your own .delphi/setup.sh reads repos, references-git and workspaces and checks each out; each linked workspace is a full clone on its own branch, pulled and set up on every run. The checkout hook, park.sh, uses name and park to keep each workspace's folders apart when you switch. Everything setup makes is git-ignored, so code never shows up as a workspace change.</a:t>
+              <a:t>Two programs read workspace.yml. CI's ci/plugins.sh reads harness and plugins and writes .claude/settings.json, and setup.sh installs exactly the plugins it enables. Your own .delphi/setup.sh reads repos, references-git and workspaces and checks each out. Each repo gets a plain clone at repos/&lt;name&gt;, on its default branch, for working on one thing at a time, and separately a bare store at worktrees/&lt;name&gt;/.bare with the default branch checked out beside it, which agents' worktrees come from; each linked workspace is a full clone on its own branch, pulled and set up on every run. The checkout hook, park.sh, uses name and park to keep each workspace's folders apart when you switch. Everything setup makes is git-ignored, so code never shows up as a workspace change.</a:t>
             </a:r>
             <a:endParaRPr lang="en-US" dirty="0"/>
           </a:p>
@@ -1394,7 +1394,7 @@
           <a:p>
             <a:r>
               <a:rPr lang="en-US" dirty="0"/>
-              <a:t>A normal ticket. You clone the workspace and run setup once. /implement makes a worktree for the ticket's branch from origin/develop and works test-first; /run-local serves that worktree; /commit applies the message format; /open-pr runs the checks and opens a draft PR into Argos develop. The skills that guide every step are inherited from the argos and application-software folders on main, but the code goes through Argos's own PRs. worktrees/ is git-ignored, so Delphi never sees it.</a:t>
+              <a:t>A normal ticket. You clone the workspace and run setup once. Agents work in worktrees, all made from worktrees/argos/.bare; the plain clone at repos/argos is yours, for one thing at a time. /implement makes a worktree for the ticket's branch from origin/develop and works test-first; /run-local serves that worktree; /commit applies the message format; /open-pr runs the checks, offers screenshots or a video for a UI change, and opens a draft PR into Argos develop. The skills that guide every step are inherited from the argos and application-software folders on main, but the code goes through Argos's own PRs. worktrees/ is git-ignored, so Delphi never sees it.</a:t>
             </a:r>
             <a:endParaRPr lang="en-US" dirty="0"/>
           </a:p>

</xml_diff>